<commit_message>
Update Baines Simmons, Kenyon, and Redline templates
Replaces the three brand templates in deck-builder with the latest
versions provided by Alex. TrustFlight template is unchanged.
Rebundled deck-builder.zip.
</commit_message>
<xml_diff>
--- a/skills/deck-builder/templates/Baines Simmons - Basic Presentation Template.pptx
+++ b/skills/deck-builder/templates/Baines Simmons - Basic Presentation Template.pptx
@@ -5,17 +5,16 @@
     <p:sldMasterId id="2147483654" r:id="rId4"/>
   </p:sldMasterIdLst>
   <p:notesMasterIdLst>
-    <p:notesMasterId r:id="rId13"/>
+    <p:notesMasterId r:id="rId12"/>
   </p:notesMasterIdLst>
   <p:sldIdLst>
     <p:sldId id="352" r:id="rId5"/>
     <p:sldId id="920" r:id="rId6"/>
-    <p:sldId id="316" r:id="rId7"/>
-    <p:sldId id="8527" r:id="rId8"/>
-    <p:sldId id="8522" r:id="rId9"/>
-    <p:sldId id="304" r:id="rId10"/>
-    <p:sldId id="305" r:id="rId11"/>
-    <p:sldId id="612" r:id="rId12"/>
+    <p:sldId id="921" r:id="rId7"/>
+    <p:sldId id="922" r:id="rId8"/>
+    <p:sldId id="923" r:id="rId9"/>
+    <p:sldId id="924" r:id="rId10"/>
+    <p:sldId id="612" r:id="rId11"/>
   </p:sldIdLst>
   <p:sldSz cx="12192000" cy="6858000"/>
   <p:notesSz cx="6858000" cy="9144000"/>
@@ -130,6 +129,186 @@
 </p188:authorLst>
 </file>
 
+<file path=ppt/revisionInfo.xml><?xml version="1.0" encoding="utf-8"?>
+<p1510:revInfo xmlns:a="http://schemas.openxmlformats.org/drawingml/2006/main" xmlns:r="http://schemas.openxmlformats.org/officeDocument/2006/relationships" xmlns:p1510="http://schemas.microsoft.com/office/powerpoint/2015/10/main">
+  <p1510:revLst>
+    <p1510:client id="{18A87E93-0E45-DC4E-A78A-9306EF4EE988}" v="1" dt="2026-06-15T10:14:06.628"/>
+  </p1510:revLst>
+</p1510:revInfo>
+</file>
+
+<file path=ppt/changesInfos/changesInfo1.xml><?xml version="1.0" encoding="utf-8"?>
+<pc:chgInfo xmlns:a="http://schemas.openxmlformats.org/drawingml/2006/main" xmlns:r="http://schemas.openxmlformats.org/officeDocument/2006/relationships" xmlns:ac="http://schemas.microsoft.com/office/drawing/2013/main/command" xmlns:pc="http://schemas.microsoft.com/office/powerpoint/2013/main/command">
+  <pc:docChgLst>
+    <pc:chgData name="Alexandru Craiu" userId="bf72ae8b-33ff-49ef-b84e-d4843c5d563a" providerId="ADAL" clId="{829A1C91-59B3-5131-847F-55174CC630BC}"/>
+    <pc:docChg chg="custSel addSld delSld modSld">
+      <pc:chgData name="Alexandru Craiu" userId="bf72ae8b-33ff-49ef-b84e-d4843c5d563a" providerId="ADAL" clId="{829A1C91-59B3-5131-847F-55174CC630BC}" dt="2026-06-15T10:15:01.617" v="35" actId="680"/>
+      <pc:docMkLst>
+        <pc:docMk/>
+      </pc:docMkLst>
+      <pc:sldChg chg="modSp mod">
+        <pc:chgData name="Alexandru Craiu" userId="bf72ae8b-33ff-49ef-b84e-d4843c5d563a" providerId="ADAL" clId="{829A1C91-59B3-5131-847F-55174CC630BC}" dt="2026-06-15T10:13:35.063" v="25" actId="20577"/>
+        <pc:sldMkLst>
+          <pc:docMk/>
+          <pc:sldMk cId="1683448074" sldId="352"/>
+        </pc:sldMkLst>
+        <pc:spChg chg="mod">
+          <ac:chgData name="Alexandru Craiu" userId="bf72ae8b-33ff-49ef-b84e-d4843c5d563a" providerId="ADAL" clId="{829A1C91-59B3-5131-847F-55174CC630BC}" dt="2026-06-15T10:13:32.949" v="17" actId="20577"/>
+          <ac:spMkLst>
+            <pc:docMk/>
+            <pc:sldMk cId="1683448074" sldId="352"/>
+            <ac:spMk id="2" creationId="{D0ED6051-63E7-ECCC-A56B-A0A982A4EC47}"/>
+          </ac:spMkLst>
+        </pc:spChg>
+        <pc:spChg chg="mod">
+          <ac:chgData name="Alexandru Craiu" userId="bf72ae8b-33ff-49ef-b84e-d4843c5d563a" providerId="ADAL" clId="{829A1C91-59B3-5131-847F-55174CC630BC}" dt="2026-06-15T10:13:35.063" v="25" actId="20577"/>
+          <ac:spMkLst>
+            <pc:docMk/>
+            <pc:sldMk cId="1683448074" sldId="352"/>
+            <ac:spMk id="3" creationId="{A01A0630-8131-4E49-089A-37F0D9289B64}"/>
+          </ac:spMkLst>
+        </pc:spChg>
+      </pc:sldChg>
+      <pc:sldChg chg="addSp delSp modSp mod">
+        <pc:chgData name="Alexandru Craiu" userId="bf72ae8b-33ff-49ef-b84e-d4843c5d563a" providerId="ADAL" clId="{829A1C91-59B3-5131-847F-55174CC630BC}" dt="2026-06-15T10:14:06.627" v="31"/>
+        <pc:sldMkLst>
+          <pc:docMk/>
+          <pc:sldMk cId="1684320835" sldId="920"/>
+        </pc:sldMkLst>
+        <pc:spChg chg="add mod">
+          <ac:chgData name="Alexandru Craiu" userId="bf72ae8b-33ff-49ef-b84e-d4843c5d563a" providerId="ADAL" clId="{829A1C91-59B3-5131-847F-55174CC630BC}" dt="2026-06-15T10:14:06.627" v="31"/>
+          <ac:spMkLst>
+            <pc:docMk/>
+            <pc:sldMk cId="1684320835" sldId="920"/>
+            <ac:spMk id="2" creationId="{6EA1A369-C17C-D5C1-D902-A23E857E351B}"/>
+          </ac:spMkLst>
+        </pc:spChg>
+        <pc:spChg chg="add mod">
+          <ac:chgData name="Alexandru Craiu" userId="bf72ae8b-33ff-49ef-b84e-d4843c5d563a" providerId="ADAL" clId="{829A1C91-59B3-5131-847F-55174CC630BC}" dt="2026-06-15T10:14:06.627" v="31"/>
+          <ac:spMkLst>
+            <pc:docMk/>
+            <pc:sldMk cId="1684320835" sldId="920"/>
+            <ac:spMk id="5" creationId="{057E1C50-CD74-14C5-AF95-0850C42E0923}"/>
+          </ac:spMkLst>
+        </pc:spChg>
+        <pc:spChg chg="del">
+          <ac:chgData name="Alexandru Craiu" userId="bf72ae8b-33ff-49ef-b84e-d4843c5d563a" providerId="ADAL" clId="{829A1C91-59B3-5131-847F-55174CC630BC}" dt="2026-06-15T10:14:06.215" v="30" actId="478"/>
+          <ac:spMkLst>
+            <pc:docMk/>
+            <pc:sldMk cId="1684320835" sldId="920"/>
+            <ac:spMk id="10" creationId="{A5B1C390-9E63-6667-A4ED-AE69B1C49F6F}"/>
+          </ac:spMkLst>
+        </pc:spChg>
+        <pc:spChg chg="del">
+          <ac:chgData name="Alexandru Craiu" userId="bf72ae8b-33ff-49ef-b84e-d4843c5d563a" providerId="ADAL" clId="{829A1C91-59B3-5131-847F-55174CC630BC}" dt="2026-06-15T10:14:06.215" v="30" actId="478"/>
+          <ac:spMkLst>
+            <pc:docMk/>
+            <pc:sldMk cId="1684320835" sldId="920"/>
+            <ac:spMk id="11" creationId="{7B392FFF-CE04-6F22-9868-A2E05725993E}"/>
+          </ac:spMkLst>
+        </pc:spChg>
+        <pc:spChg chg="del">
+          <ac:chgData name="Alexandru Craiu" userId="bf72ae8b-33ff-49ef-b84e-d4843c5d563a" providerId="ADAL" clId="{829A1C91-59B3-5131-847F-55174CC630BC}" dt="2026-06-15T10:14:06.215" v="30" actId="478"/>
+          <ac:spMkLst>
+            <pc:docMk/>
+            <pc:sldMk cId="1684320835" sldId="920"/>
+            <ac:spMk id="12" creationId="{898D6E48-4054-B90C-D21D-B19513906402}"/>
+          </ac:spMkLst>
+        </pc:spChg>
+        <pc:spChg chg="del">
+          <ac:chgData name="Alexandru Craiu" userId="bf72ae8b-33ff-49ef-b84e-d4843c5d563a" providerId="ADAL" clId="{829A1C91-59B3-5131-847F-55174CC630BC}" dt="2026-06-15T10:14:06.215" v="30" actId="478"/>
+          <ac:spMkLst>
+            <pc:docMk/>
+            <pc:sldMk cId="1684320835" sldId="920"/>
+            <ac:spMk id="13" creationId="{956B4C66-97D5-FE92-971B-27FAA394C287}"/>
+          </ac:spMkLst>
+        </pc:spChg>
+        <pc:spChg chg="add mod">
+          <ac:chgData name="Alexandru Craiu" userId="bf72ae8b-33ff-49ef-b84e-d4843c5d563a" providerId="ADAL" clId="{829A1C91-59B3-5131-847F-55174CC630BC}" dt="2026-06-15T10:14:06.627" v="31"/>
+          <ac:spMkLst>
+            <pc:docMk/>
+            <pc:sldMk cId="1684320835" sldId="920"/>
+            <ac:spMk id="14" creationId="{697CBC8B-96C3-C677-F9E4-DB955087AEFA}"/>
+          </ac:spMkLst>
+        </pc:spChg>
+        <pc:spChg chg="add mod">
+          <ac:chgData name="Alexandru Craiu" userId="bf72ae8b-33ff-49ef-b84e-d4843c5d563a" providerId="ADAL" clId="{829A1C91-59B3-5131-847F-55174CC630BC}" dt="2026-06-15T10:14:06.627" v="31"/>
+          <ac:spMkLst>
+            <pc:docMk/>
+            <pc:sldMk cId="1684320835" sldId="920"/>
+            <ac:spMk id="15" creationId="{AE373CF3-FDAE-40A2-BE9A-A87F9CE690E9}"/>
+          </ac:spMkLst>
+        </pc:spChg>
+        <pc:spChg chg="add mod">
+          <ac:chgData name="Alexandru Craiu" userId="bf72ae8b-33ff-49ef-b84e-d4843c5d563a" providerId="ADAL" clId="{829A1C91-59B3-5131-847F-55174CC630BC}" dt="2026-06-15T10:14:06.627" v="31"/>
+          <ac:spMkLst>
+            <pc:docMk/>
+            <pc:sldMk cId="1684320835" sldId="920"/>
+            <ac:spMk id="16" creationId="{5E8A48D2-25B1-EFC0-80C5-1FCAFA3EB822}"/>
+          </ac:spMkLst>
+        </pc:spChg>
+      </pc:sldChg>
+      <pc:sldChg chg="new">
+        <pc:chgData name="Alexandru Craiu" userId="bf72ae8b-33ff-49ef-b84e-d4843c5d563a" providerId="ADAL" clId="{829A1C91-59B3-5131-847F-55174CC630BC}" dt="2026-06-15T10:14:30.151" v="32" actId="680"/>
+        <pc:sldMkLst>
+          <pc:docMk/>
+          <pc:sldMk cId="3637964964" sldId="921"/>
+        </pc:sldMkLst>
+      </pc:sldChg>
+      <pc:sldChg chg="new">
+        <pc:chgData name="Alexandru Craiu" userId="bf72ae8b-33ff-49ef-b84e-d4843c5d563a" providerId="ADAL" clId="{829A1C91-59B3-5131-847F-55174CC630BC}" dt="2026-06-15T10:14:39.372" v="33" actId="680"/>
+        <pc:sldMkLst>
+          <pc:docMk/>
+          <pc:sldMk cId="2493090838" sldId="922"/>
+        </pc:sldMkLst>
+      </pc:sldChg>
+      <pc:sldChg chg="new">
+        <pc:chgData name="Alexandru Craiu" userId="bf72ae8b-33ff-49ef-b84e-d4843c5d563a" providerId="ADAL" clId="{829A1C91-59B3-5131-847F-55174CC630BC}" dt="2026-06-15T10:14:48.813" v="34" actId="680"/>
+        <pc:sldMkLst>
+          <pc:docMk/>
+          <pc:sldMk cId="3820088869" sldId="923"/>
+        </pc:sldMkLst>
+      </pc:sldChg>
+      <pc:sldChg chg="new">
+        <pc:chgData name="Alexandru Craiu" userId="bf72ae8b-33ff-49ef-b84e-d4843c5d563a" providerId="ADAL" clId="{829A1C91-59B3-5131-847F-55174CC630BC}" dt="2026-06-15T10:15:01.617" v="35" actId="680"/>
+        <pc:sldMkLst>
+          <pc:docMk/>
+          <pc:sldMk cId="4141893985" sldId="924"/>
+        </pc:sldMkLst>
+      </pc:sldChg>
+      <pc:sldChg chg="del">
+        <pc:chgData name="Alexandru Craiu" userId="bf72ae8b-33ff-49ef-b84e-d4843c5d563a" providerId="ADAL" clId="{829A1C91-59B3-5131-847F-55174CC630BC}" dt="2026-06-15T10:13:56.601" v="26" actId="2696"/>
+        <pc:sldMkLst>
+          <pc:docMk/>
+          <pc:sldMk cId="0" sldId="8529"/>
+        </pc:sldMkLst>
+      </pc:sldChg>
+      <pc:sldChg chg="del">
+        <pc:chgData name="Alexandru Craiu" userId="bf72ae8b-33ff-49ef-b84e-d4843c5d563a" providerId="ADAL" clId="{829A1C91-59B3-5131-847F-55174CC630BC}" dt="2026-06-15T10:13:56.606" v="27" actId="2696"/>
+        <pc:sldMkLst>
+          <pc:docMk/>
+          <pc:sldMk cId="0" sldId="8531"/>
+        </pc:sldMkLst>
+      </pc:sldChg>
+      <pc:sldChg chg="del">
+        <pc:chgData name="Alexandru Craiu" userId="bf72ae8b-33ff-49ef-b84e-d4843c5d563a" providerId="ADAL" clId="{829A1C91-59B3-5131-847F-55174CC630BC}" dt="2026-06-15T10:13:56.611" v="28" actId="2696"/>
+        <pc:sldMkLst>
+          <pc:docMk/>
+          <pc:sldMk cId="0" sldId="8533"/>
+        </pc:sldMkLst>
+      </pc:sldChg>
+      <pc:sldChg chg="del">
+        <pc:chgData name="Alexandru Craiu" userId="bf72ae8b-33ff-49ef-b84e-d4843c5d563a" providerId="ADAL" clId="{829A1C91-59B3-5131-847F-55174CC630BC}" dt="2026-06-15T10:13:56.615" v="29" actId="2696"/>
+        <pc:sldMkLst>
+          <pc:docMk/>
+          <pc:sldMk cId="0" sldId="8535"/>
+        </pc:sldMkLst>
+      </pc:sldChg>
+    </pc:docChg>
+  </pc:docChgLst>
+</pc:chgInfo>
+</file>
+
 <file path=ppt/notesMasters/notesMaster1.xml><?xml version="1.0" encoding="utf-8"?>
 <p:notesMaster xmlns:a="http://schemas.openxmlformats.org/drawingml/2006/main" xmlns:r="http://schemas.openxmlformats.org/officeDocument/2006/relationships" xmlns:p="http://schemas.openxmlformats.org/presentationml/2006/main">
   <p:cSld>
@@ -212,7 +391,7 @@
           <a:p>
             <a:fld id="{FD3DFF91-E63B-E948-B3A5-1D1BF1CECDF7}" type="datetimeFigureOut">
               <a:rPr lang="en-US" smtClean="0"/>
-              <a:t>5/28/26</a:t>
+              <a:t>6/15/26</a:t>
             </a:fld>
             <a:endParaRPr lang="en-US"/>
           </a:p>
@@ -480,267 +659,6 @@
 </p:notesMaster>
 </file>
 
-<file path=ppt/notesSlides/notesSlide1.xml><?xml version="1.0" encoding="utf-8"?>
-<p:notes xmlns:a="http://schemas.openxmlformats.org/drawingml/2006/main" xmlns:r="http://schemas.openxmlformats.org/officeDocument/2006/relationships" xmlns:p="http://schemas.openxmlformats.org/presentationml/2006/main">
-  <p:cSld>
-    <p:spTree>
-      <p:nvGrpSpPr>
-        <p:cNvPr id="1" name=""/>
-        <p:cNvGrpSpPr/>
-        <p:nvPr/>
-      </p:nvGrpSpPr>
-      <p:grpSpPr>
-        <a:xfrm>
-          <a:off x="0" y="0"/>
-          <a:ext cx="0" cy="0"/>
-          <a:chOff x="0" y="0"/>
-          <a:chExt cx="0" cy="0"/>
-        </a:xfrm>
-      </p:grpSpPr>
-      <p:sp>
-        <p:nvSpPr>
-          <p:cNvPr id="2" name="Slide Image Placeholder 1"/>
-          <p:cNvSpPr>
-            <a:spLocks noGrp="1" noRot="1" noChangeAspect="1"/>
-          </p:cNvSpPr>
-          <p:nvPr>
-            <p:ph type="sldImg"/>
-          </p:nvPr>
-        </p:nvSpPr>
-        <p:spPr/>
-      </p:sp>
-      <p:sp>
-        <p:nvSpPr>
-          <p:cNvPr id="3" name="Notes Placeholder 2"/>
-          <p:cNvSpPr>
-            <a:spLocks noGrp="1"/>
-          </p:cNvSpPr>
-          <p:nvPr>
-            <p:ph type="body" idx="1"/>
-          </p:nvPr>
-        </p:nvSpPr>
-        <p:spPr/>
-        <p:txBody>
-          <a:bodyPr/>
-          <a:lstStyle/>
-          <a:p>
-            <a:pPr algn="l"/>
-            <a:r>
-              <a:rPr lang="en-US" dirty="0"/>
-              <a:t>1. </a:t>
-            </a:r>
-            <a:r>
-              <a:rPr lang="en-GB" sz="1800" b="1" dirty="0">
-                <a:solidFill>
-                  <a:srgbClr val="FFFFFF"/>
-                </a:solidFill>
-                <a:latin typeface="Open Sans SemiBold" pitchFamily="2" charset="0"/>
-                <a:ea typeface="Open Sans SemiBold" pitchFamily="2" charset="0"/>
-                <a:cs typeface="Open Sans SemiBold" pitchFamily="2" charset="0"/>
-              </a:rPr>
-              <a:t>Scale &amp; Growth</a:t>
-            </a:r>
-          </a:p>
-          <a:p>
-            <a:pPr algn="l"/>
-            <a:r>
-              <a:rPr lang="en-GB" sz="1200" dirty="0">
-                <a:solidFill>
-                  <a:srgbClr val="E0E7F5"/>
-                </a:solidFill>
-                <a:latin typeface="Open Sans Light"/>
-              </a:rPr>
-              <a:t>Serving 10M+ passengers annually, with continued expansion placing new demands on safety governance across a multi-stakeholder environment.</a:t>
-            </a:r>
-          </a:p>
-          <a:p>
-            <a:endParaRPr lang="en-US" dirty="0"/>
-          </a:p>
-          <a:p>
-            <a:pPr algn="l"/>
-            <a:r>
-              <a:rPr lang="en-US" dirty="0"/>
-              <a:t>2. </a:t>
-            </a:r>
-            <a:r>
-              <a:rPr lang="en-GB" sz="1800" b="1" dirty="0">
-                <a:solidFill>
-                  <a:srgbClr val="FFFFFF"/>
-                </a:solidFill>
-                <a:latin typeface="Open Sans SemiBold" pitchFamily="2" charset="0"/>
-                <a:ea typeface="Open Sans SemiBold" pitchFamily="2" charset="0"/>
-                <a:cs typeface="Open Sans SemiBold" pitchFamily="2" charset="0"/>
-              </a:rPr>
-              <a:t>Regulatory Landscape</a:t>
-            </a:r>
-          </a:p>
-          <a:p>
-            <a:pPr algn="l"/>
-            <a:r>
-              <a:rPr lang="en-GB" sz="1200" dirty="0">
-                <a:solidFill>
-                  <a:srgbClr val="E0E7F5"/>
-                </a:solidFill>
-                <a:latin typeface="Open Sans Light"/>
-              </a:rPr>
-              <a:t>CAA oversight spanning airside, landside, and terminal operations — diverse reporting requirements handled in one place.</a:t>
-            </a:r>
-          </a:p>
-          <a:p>
-            <a:endParaRPr lang="en-US" dirty="0"/>
-          </a:p>
-          <a:p>
-            <a:pPr algn="l"/>
-            <a:r>
-              <a:rPr lang="en-US" dirty="0"/>
-              <a:t>3. </a:t>
-            </a:r>
-            <a:r>
-              <a:rPr lang="en-GB" sz="1800" b="1" dirty="0">
-                <a:solidFill>
-                  <a:srgbClr val="FFFFFF"/>
-                </a:solidFill>
-                <a:latin typeface="Open Sans SemiBold" pitchFamily="2" charset="0"/>
-                <a:ea typeface="Open Sans SemiBold" pitchFamily="2" charset="0"/>
-                <a:cs typeface="Open Sans SemiBold" pitchFamily="2" charset="0"/>
-              </a:rPr>
-              <a:t>Operational Breadth</a:t>
-            </a:r>
-          </a:p>
-          <a:p>
-            <a:pPr algn="l"/>
-            <a:r>
-              <a:rPr lang="en-GB" sz="1200" dirty="0">
-                <a:solidFill>
-                  <a:srgbClr val="E0E7F5"/>
-                </a:solidFill>
-                <a:latin typeface="Open Sans Light"/>
-              </a:rPr>
-              <a:t>Ground handling, construction, retail, and passenger services — a mix that demands configurable workflows and visibility across departments.</a:t>
-            </a:r>
-          </a:p>
-        </p:txBody>
-      </p:sp>
-      <p:sp>
-        <p:nvSpPr>
-          <p:cNvPr id="4" name="Slide Number Placeholder 3"/>
-          <p:cNvSpPr>
-            <a:spLocks noGrp="1"/>
-          </p:cNvSpPr>
-          <p:nvPr>
-            <p:ph type="sldNum" sz="quarter" idx="5"/>
-          </p:nvPr>
-        </p:nvSpPr>
-        <p:spPr/>
-        <p:txBody>
-          <a:bodyPr/>
-          <a:lstStyle/>
-          <a:p>
-            <a:fld id="{BEB95CE4-0521-0C49-933F-6556F583EA40}" type="slidenum">
-              <a:rPr lang="en-US" smtClean="0"/>
-              <a:t>4</a:t>
-            </a:fld>
-            <a:endParaRPr lang="en-US"/>
-          </a:p>
-        </p:txBody>
-      </p:sp>
-    </p:spTree>
-    <p:extLst>
-      <p:ext uri="{BB962C8B-B14F-4D97-AF65-F5344CB8AC3E}">
-        <p14:creationId xmlns:p14="http://schemas.microsoft.com/office/powerpoint/2010/main" val="1698852535"/>
-      </p:ext>
-    </p:extLst>
-  </p:cSld>
-  <p:clrMapOvr>
-    <a:masterClrMapping/>
-  </p:clrMapOvr>
-</p:notes>
-</file>
-
-<file path=ppt/notesSlides/notesSlide2.xml><?xml version="1.0" encoding="utf-8"?>
-<p:notes xmlns:a="http://schemas.openxmlformats.org/drawingml/2006/main" xmlns:r="http://schemas.openxmlformats.org/officeDocument/2006/relationships" xmlns:p="http://schemas.openxmlformats.org/presentationml/2006/main">
-  <p:cSld>
-    <p:spTree>
-      <p:nvGrpSpPr>
-        <p:cNvPr id="1" name=""/>
-        <p:cNvGrpSpPr/>
-        <p:nvPr/>
-      </p:nvGrpSpPr>
-      <p:grpSpPr>
-        <a:xfrm>
-          <a:off x="0" y="0"/>
-          <a:ext cx="0" cy="0"/>
-          <a:chOff x="0" y="0"/>
-          <a:chExt cx="0" cy="0"/>
-        </a:xfrm>
-      </p:grpSpPr>
-      <p:sp>
-        <p:nvSpPr>
-          <p:cNvPr id="2" name="Slide Image Placeholder 1"/>
-          <p:cNvSpPr>
-            <a:spLocks noGrp="1" noRot="1" noChangeAspect="1"/>
-          </p:cNvSpPr>
-          <p:nvPr>
-            <p:ph type="sldImg"/>
-          </p:nvPr>
-        </p:nvSpPr>
-        <p:spPr/>
-      </p:sp>
-      <p:sp>
-        <p:nvSpPr>
-          <p:cNvPr id="3" name="Notes Placeholder 2"/>
-          <p:cNvSpPr>
-            <a:spLocks noGrp="1"/>
-          </p:cNvSpPr>
-          <p:nvPr>
-            <p:ph type="body" idx="1"/>
-          </p:nvPr>
-        </p:nvSpPr>
-        <p:spPr/>
-        <p:txBody>
-          <a:bodyPr/>
-          <a:lstStyle/>
-          <a:p>
-            <a:endParaRPr lang="en-US" dirty="0"/>
-          </a:p>
-        </p:txBody>
-      </p:sp>
-      <p:sp>
-        <p:nvSpPr>
-          <p:cNvPr id="4" name="Slide Number Placeholder 3"/>
-          <p:cNvSpPr>
-            <a:spLocks noGrp="1"/>
-          </p:cNvSpPr>
-          <p:nvPr>
-            <p:ph type="sldNum" sz="quarter" idx="5"/>
-          </p:nvPr>
-        </p:nvSpPr>
-        <p:spPr/>
-        <p:txBody>
-          <a:bodyPr/>
-          <a:lstStyle/>
-          <a:p>
-            <a:fld id="{BEB95CE4-0521-0C49-933F-6556F583EA40}" type="slidenum">
-              <a:rPr lang="en-US" smtClean="0"/>
-              <a:t>5</a:t>
-            </a:fld>
-            <a:endParaRPr lang="en-US"/>
-          </a:p>
-        </p:txBody>
-      </p:sp>
-    </p:spTree>
-    <p:extLst>
-      <p:ext uri="{BB962C8B-B14F-4D97-AF65-F5344CB8AC3E}">
-        <p14:creationId xmlns:p14="http://schemas.microsoft.com/office/powerpoint/2010/main" val="1698852535"/>
-      </p:ext>
-    </p:extLst>
-  </p:cSld>
-  <p:clrMapOvr>
-    <a:masterClrMapping/>
-  </p:clrMapOvr>
-</p:notes>
-</file>
-
 <file path=ppt/slideLayouts/slideLayout1.xml><?xml version="1.0" encoding="utf-8"?>
 <p:sldLayout xmlns:a="http://schemas.openxmlformats.org/drawingml/2006/main" xmlns:r="http://schemas.openxmlformats.org/officeDocument/2006/relationships" xmlns:p="http://schemas.openxmlformats.org/presentationml/2006/main" preserve="1" userDrawn="1">
   <p:cSld name="Dark - Title">
@@ -1007,35 +925,6 @@
           </a:p>
         </p:txBody>
       </p:sp>
-      <p:pic>
-        <p:nvPicPr>
-          <p:cNvPr id="6" name="Picture 5">
-            <a:extLst>
-              <a:ext uri="{FF2B5EF4-FFF2-40B4-BE49-F238E27FC236}">
-                <a16:creationId xmlns:a16="http://schemas.microsoft.com/office/drawing/2014/main" id="{90EBB041-6C25-006B-B2E3-00DB27F26BB0}"/>
-              </a:ext>
-            </a:extLst>
-          </p:cNvPr>
-          <p:cNvPicPr>
-            <a:picLocks noChangeAspect="1"/>
-          </p:cNvPicPr>
-          <p:nvPr userDrawn="1"/>
-        </p:nvPicPr>
-        <p:blipFill>
-          <a:blip r:embed="rId3"/>
-          <a:srcRect/>
-          <a:stretch/>
-        </p:blipFill>
-        <p:spPr>
-          <a:xfrm>
-            <a:off x="673784" y="3068575"/>
-            <a:ext cx="3434827" cy="576311"/>
-          </a:xfrm>
-          <a:prstGeom prst="rect">
-            <a:avLst/>
-          </a:prstGeom>
-        </p:spPr>
-      </p:pic>
       <p:sp>
         <p:nvSpPr>
           <p:cNvPr id="7" name="Rounded Rectangle 6">
@@ -1050,8 +939,8 @@
         </p:nvSpPr>
         <p:spPr>
           <a:xfrm>
-            <a:off x="4593515" y="-1269401"/>
-            <a:ext cx="8961120" cy="4914288"/>
+            <a:off x="5496673" y="-1269401"/>
+            <a:ext cx="8057961" cy="4914288"/>
           </a:xfrm>
           <a:prstGeom prst="roundRect">
             <a:avLst>
@@ -1090,6 +979,71 @@
           </a:p>
         </p:txBody>
       </p:sp>
+      <p:pic>
+        <p:nvPicPr>
+          <p:cNvPr id="3" name="Picture 2">
+            <a:extLst>
+              <a:ext uri="{FF2B5EF4-FFF2-40B4-BE49-F238E27FC236}">
+                <a16:creationId xmlns:a16="http://schemas.microsoft.com/office/drawing/2014/main" id="{87B78FE2-5FD6-3FEF-14BE-3F1B233D6D4B}"/>
+              </a:ext>
+            </a:extLst>
+          </p:cNvPr>
+          <p:cNvPicPr>
+            <a:picLocks noChangeAspect="1"/>
+          </p:cNvPicPr>
+          <p:nvPr userDrawn="1"/>
+        </p:nvPicPr>
+        <p:blipFill>
+          <a:blip r:embed="rId3"/>
+          <a:srcRect/>
+          <a:stretch/>
+        </p:blipFill>
+        <p:spPr>
+          <a:xfrm>
+            <a:off x="9141449" y="2971800"/>
+            <a:ext cx="2325905" cy="390251"/>
+          </a:xfrm>
+          <a:prstGeom prst="rect">
+            <a:avLst/>
+          </a:prstGeom>
+        </p:spPr>
+      </p:pic>
+      <p:pic>
+        <p:nvPicPr>
+          <p:cNvPr id="5" name="Graphic 4">
+            <a:extLst>
+              <a:ext uri="{FF2B5EF4-FFF2-40B4-BE49-F238E27FC236}">
+                <a16:creationId xmlns:a16="http://schemas.microsoft.com/office/drawing/2014/main" id="{12F68665-CAED-3887-76B9-1948E5D1A29A}"/>
+              </a:ext>
+            </a:extLst>
+          </p:cNvPr>
+          <p:cNvPicPr>
+            <a:picLocks noChangeAspect="1"/>
+          </p:cNvPicPr>
+          <p:nvPr userDrawn="1"/>
+        </p:nvPicPr>
+        <p:blipFill>
+          <a:blip>
+            <a:extLst>
+              <a:ext uri="{96DAC541-7B7A-43D3-8B79-37D633B846F1}">
+                <asvg:svgBlip xmlns:asvg="http://schemas.microsoft.com/office/drawing/2016/SVG/main" r:embed="rId4"/>
+              </a:ext>
+            </a:extLst>
+          </a:blip>
+          <a:stretch>
+            <a:fillRect/>
+          </a:stretch>
+        </p:blipFill>
+        <p:spPr>
+          <a:xfrm>
+            <a:off x="1519681" y="2880000"/>
+            <a:ext cx="3717337" cy="540703"/>
+          </a:xfrm>
+          <a:prstGeom prst="rect">
+            <a:avLst/>
+          </a:prstGeom>
+        </p:spPr>
+      </p:pic>
     </p:spTree>
     <p:extLst>
       <p:ext uri="{BB962C8B-B14F-4D97-AF65-F5344CB8AC3E}">
@@ -8953,7 +8907,13 @@
           <a:bodyPr/>
           <a:lstStyle/>
           <a:p>
-            <a:endParaRPr lang="en-US"/>
+            <a:r>
+              <a:rPr lang="en-GB" dirty="0">
+                <a:latin typeface="Open Sans Light"/>
+              </a:rPr>
+              <a:t>Presentation Title</a:t>
+            </a:r>
+            <a:endParaRPr lang="en-US" dirty="0"/>
           </a:p>
         </p:txBody>
       </p:sp>
@@ -8973,14 +8933,25 @@
             <p:ph type="body" sz="quarter" idx="10"/>
           </p:nvPr>
         </p:nvSpPr>
-        <p:spPr/>
-        <p:txBody>
-          <a:bodyPr lIns="0" tIns="0" rIns="0" bIns="0">
+        <p:spPr>
+          <a:xfrm>
+            <a:off x="1519681" y="4890961"/>
+            <a:ext cx="7754948" cy="332399"/>
+          </a:xfrm>
+        </p:spPr>
+        <p:txBody>
+          <a:bodyPr wrap="square" lIns="0" tIns="0" rIns="0" bIns="0">
             <a:spAutoFit/>
           </a:bodyPr>
           <a:lstStyle/>
           <a:p>
-            <a:endParaRPr lang="en-US"/>
+            <a:r>
+              <a:rPr lang="en-GB" dirty="0">
+                <a:latin typeface="Open Sans Light"/>
+              </a:rPr>
+              <a:t>Subtitle</a:t>
+            </a:r>
+            <a:endParaRPr lang="en-US" dirty="0"/>
           </a:p>
         </p:txBody>
       </p:sp>
@@ -9009,7 +8980,7 @@
           <a:p>
             <a:fld id="{C8A1BA17-5FCD-E84E-BA65-AF5582366495}" type="datetime4">
               <a:rPr lang="en-GB" smtClean="0"/>
-              <a:t>28 May 2026</a:t>
+              <a:t>15 June 2026</a:t>
             </a:fld>
             <a:endParaRPr lang="en-US" dirty="0"/>
           </a:p>
@@ -9241,10 +9212,10 @@
       </p:sp>
       <p:sp>
         <p:nvSpPr>
-          <p:cNvPr id="10" name="Google Shape;110;p16">
-            <a:extLst>
-              <a:ext uri="{FF2B5EF4-FFF2-40B4-BE49-F238E27FC236}">
-                <a16:creationId xmlns:a16="http://schemas.microsoft.com/office/drawing/2014/main" id="{A5B1C390-9E63-6667-A4ED-AE69B1C49F6F}"/>
+          <p:cNvPr id="2" name="Google Shape;110;p16">
+            <a:extLst>
+              <a:ext uri="{FF2B5EF4-FFF2-40B4-BE49-F238E27FC236}">
+                <a16:creationId xmlns:a16="http://schemas.microsoft.com/office/drawing/2014/main" id="{6EA1A369-C17C-D5C1-D902-A23E857E351B}"/>
               </a:ext>
             </a:extLst>
           </p:cNvPr>
@@ -9310,10 +9281,10 @@
       </p:sp>
       <p:sp>
         <p:nvSpPr>
-          <p:cNvPr id="11" name="Google Shape;110;p16">
-            <a:extLst>
-              <a:ext uri="{FF2B5EF4-FFF2-40B4-BE49-F238E27FC236}">
-                <a16:creationId xmlns:a16="http://schemas.microsoft.com/office/drawing/2014/main" id="{7B392FFF-CE04-6F22-9868-A2E05725993E}"/>
+          <p:cNvPr id="5" name="Google Shape;110;p16">
+            <a:extLst>
+              <a:ext uri="{FF2B5EF4-FFF2-40B4-BE49-F238E27FC236}">
+                <a16:creationId xmlns:a16="http://schemas.microsoft.com/office/drawing/2014/main" id="{057E1C50-CD74-14C5-AF95-0850C42E0923}"/>
               </a:ext>
             </a:extLst>
           </p:cNvPr>
@@ -9379,10 +9350,10 @@
       </p:sp>
       <p:sp>
         <p:nvSpPr>
-          <p:cNvPr id="12" name="Google Shape;110;p16">
-            <a:extLst>
-              <a:ext uri="{FF2B5EF4-FFF2-40B4-BE49-F238E27FC236}">
-                <a16:creationId xmlns:a16="http://schemas.microsoft.com/office/drawing/2014/main" id="{898D6E48-4054-B90C-D21D-B19513906402}"/>
+          <p:cNvPr id="14" name="Google Shape;110;p16">
+            <a:extLst>
+              <a:ext uri="{FF2B5EF4-FFF2-40B4-BE49-F238E27FC236}">
+                <a16:creationId xmlns:a16="http://schemas.microsoft.com/office/drawing/2014/main" id="{697CBC8B-96C3-C677-F9E4-DB955087AEFA}"/>
               </a:ext>
             </a:extLst>
           </p:cNvPr>
@@ -9448,10 +9419,10 @@
       </p:sp>
       <p:sp>
         <p:nvSpPr>
-          <p:cNvPr id="13" name="Google Shape;110;p16">
-            <a:extLst>
-              <a:ext uri="{FF2B5EF4-FFF2-40B4-BE49-F238E27FC236}">
-                <a16:creationId xmlns:a16="http://schemas.microsoft.com/office/drawing/2014/main" id="{956B4C66-97D5-FE92-971B-27FAA394C287}"/>
+          <p:cNvPr id="15" name="Google Shape;110;p16">
+            <a:extLst>
+              <a:ext uri="{FF2B5EF4-FFF2-40B4-BE49-F238E27FC236}">
+                <a16:creationId xmlns:a16="http://schemas.microsoft.com/office/drawing/2014/main" id="{AE373CF3-FDAE-40A2-BE9A-A87F9CE690E9}"/>
               </a:ext>
             </a:extLst>
           </p:cNvPr>
@@ -9517,10 +9488,10 @@
       </p:sp>
       <p:sp>
         <p:nvSpPr>
-          <p:cNvPr id="14" name="Google Shape;110;p16">
-            <a:extLst>
-              <a:ext uri="{FF2B5EF4-FFF2-40B4-BE49-F238E27FC236}">
-                <a16:creationId xmlns:a16="http://schemas.microsoft.com/office/drawing/2014/main" id="{3F0E9F40-EF00-9DC1-3A06-95F66587E57C}"/>
+          <p:cNvPr id="16" name="Google Shape;110;p16">
+            <a:extLst>
+              <a:ext uri="{FF2B5EF4-FFF2-40B4-BE49-F238E27FC236}">
+                <a16:creationId xmlns:a16="http://schemas.microsoft.com/office/drawing/2014/main" id="{5E8A48D2-25B1-EFC0-80C5-1FCAFA3EB822}"/>
               </a:ext>
             </a:extLst>
           </p:cNvPr>
@@ -9619,7 +9590,7 @@
           <p:cNvPr id="2" name="Title 1">
             <a:extLst>
               <a:ext uri="{FF2B5EF4-FFF2-40B4-BE49-F238E27FC236}">
-                <a16:creationId xmlns:a16="http://schemas.microsoft.com/office/drawing/2014/main" id="{B0B41E22-4416-A494-EF9C-ECE7F9361FFE}"/>
+                <a16:creationId xmlns:a16="http://schemas.microsoft.com/office/drawing/2014/main" id="{2230EC8F-0B57-78B2-A133-506B81509863}"/>
               </a:ext>
             </a:extLst>
           </p:cNvPr>
@@ -9630,29 +9601,21 @@
             <p:ph type="title"/>
           </p:nvPr>
         </p:nvSpPr>
-        <p:spPr>
-          <a:xfrm>
-            <a:off x="540001" y="2875002"/>
-            <a:ext cx="8331626" cy="553998"/>
-          </a:xfrm>
-        </p:spPr>
+        <p:spPr/>
         <p:txBody>
           <a:bodyPr/>
           <a:lstStyle/>
           <a:p>
-            <a:r>
-              <a:rPr lang="en-US" sz="4000" dirty="0"/>
-              <a:t>Section Break</a:t>
-            </a:r>
-          </a:p>
-        </p:txBody>
-      </p:sp>
-      <p:sp>
-        <p:nvSpPr>
-          <p:cNvPr id="4" name="Slide Number Placeholder 3">
-            <a:extLst>
-              <a:ext uri="{FF2B5EF4-FFF2-40B4-BE49-F238E27FC236}">
-                <a16:creationId xmlns:a16="http://schemas.microsoft.com/office/drawing/2014/main" id="{CA7F385A-EDA9-765B-DCFE-F86BCA14F7AE}"/>
+            <a:endParaRPr lang="en-US"/>
+          </a:p>
+        </p:txBody>
+      </p:sp>
+      <p:sp>
+        <p:nvSpPr>
+          <p:cNvPr id="3" name="Slide Number Placeholder 2">
+            <a:extLst>
+              <a:ext uri="{FF2B5EF4-FFF2-40B4-BE49-F238E27FC236}">
+                <a16:creationId xmlns:a16="http://schemas.microsoft.com/office/drawing/2014/main" id="{D80DA557-0021-2D2E-BD45-24013316AB3F}"/>
               </a:ext>
             </a:extLst>
           </p:cNvPr>
@@ -9679,164 +9642,46 @@
       </p:sp>
       <p:sp>
         <p:nvSpPr>
-          <p:cNvPr id="3" name="Footer Placeholder 4">
-            <a:extLst>
-              <a:ext uri="{FF2B5EF4-FFF2-40B4-BE49-F238E27FC236}">
-                <a16:creationId xmlns:a16="http://schemas.microsoft.com/office/drawing/2014/main" id="{3B3D7ED2-BB62-C756-333E-8AFB5FFF1C43}"/>
-              </a:ext>
-            </a:extLst>
-          </p:cNvPr>
-          <p:cNvSpPr txBox="1">
-            <a:spLocks/>
+          <p:cNvPr id="4" name="Footer Placeholder 3">
+            <a:extLst>
+              <a:ext uri="{FF2B5EF4-FFF2-40B4-BE49-F238E27FC236}">
+                <a16:creationId xmlns:a16="http://schemas.microsoft.com/office/drawing/2014/main" id="{2B66B527-A3A5-6AB7-55CE-51685005E3F2}"/>
+              </a:ext>
+            </a:extLst>
+          </p:cNvPr>
+          <p:cNvSpPr>
+            <a:spLocks noGrp="1"/>
           </p:cNvSpPr>
-          <p:nvPr/>
-        </p:nvSpPr>
-        <p:spPr>
-          <a:xfrm>
-            <a:off x="540000" y="6461968"/>
-            <a:ext cx="3078186" cy="153888"/>
-          </a:xfrm>
-          <a:prstGeom prst="rect">
-            <a:avLst/>
-          </a:prstGeom>
-        </p:spPr>
-        <p:txBody>
-          <a:bodyPr vert="horz" wrap="square" lIns="0" tIns="0" rIns="0" bIns="0" rtlCol="0" anchor="ctr">
-            <a:spAutoFit/>
-          </a:bodyPr>
-          <a:lstStyle>
-            <a:defPPr>
-              <a:defRPr lang="en-US"/>
-            </a:defPPr>
-            <a:lvl1pPr marL="0" algn="l" defTabSz="914355" rtl="0" eaLnBrk="1" latinLnBrk="0" hangingPunct="1">
-              <a:defRPr sz="1000" b="0" i="0" kern="1200">
-                <a:solidFill>
-                  <a:srgbClr val="242D41"/>
-                </a:solidFill>
-                <a:latin typeface="Open Sans Light" panose="020B0306030504020204" pitchFamily="34" charset="0"/>
-                <a:ea typeface="Open Sans Light" panose="020B0306030504020204" pitchFamily="34" charset="0"/>
-                <a:cs typeface="Open Sans Light" panose="020B0306030504020204" pitchFamily="34" charset="0"/>
-              </a:defRPr>
-            </a:lvl1pPr>
-            <a:lvl2pPr marL="457177" algn="l" defTabSz="914355" rtl="0" eaLnBrk="1" latinLnBrk="0" hangingPunct="1">
-              <a:defRPr sz="1800" kern="1200">
-                <a:solidFill>
-                  <a:schemeClr val="tx1"/>
-                </a:solidFill>
-                <a:latin typeface="+mn-lt"/>
-                <a:ea typeface="+mn-ea"/>
-                <a:cs typeface="+mn-cs"/>
-              </a:defRPr>
-            </a:lvl2pPr>
-            <a:lvl3pPr marL="914355" algn="l" defTabSz="914355" rtl="0" eaLnBrk="1" latinLnBrk="0" hangingPunct="1">
-              <a:defRPr sz="1800" kern="1200">
-                <a:solidFill>
-                  <a:schemeClr val="tx1"/>
-                </a:solidFill>
-                <a:latin typeface="+mn-lt"/>
-                <a:ea typeface="+mn-ea"/>
-                <a:cs typeface="+mn-cs"/>
-              </a:defRPr>
-            </a:lvl3pPr>
-            <a:lvl4pPr marL="1371532" algn="l" defTabSz="914355" rtl="0" eaLnBrk="1" latinLnBrk="0" hangingPunct="1">
-              <a:defRPr sz="1800" kern="1200">
-                <a:solidFill>
-                  <a:schemeClr val="tx1"/>
-                </a:solidFill>
-                <a:latin typeface="+mn-lt"/>
-                <a:ea typeface="+mn-ea"/>
-                <a:cs typeface="+mn-cs"/>
-              </a:defRPr>
-            </a:lvl4pPr>
-            <a:lvl5pPr marL="1828709" algn="l" defTabSz="914355" rtl="0" eaLnBrk="1" latinLnBrk="0" hangingPunct="1">
-              <a:defRPr sz="1800" kern="1200">
-                <a:solidFill>
-                  <a:schemeClr val="tx1"/>
-                </a:solidFill>
-                <a:latin typeface="+mn-lt"/>
-                <a:ea typeface="+mn-ea"/>
-                <a:cs typeface="+mn-cs"/>
-              </a:defRPr>
-            </a:lvl5pPr>
-            <a:lvl6pPr marL="2285886" algn="l" defTabSz="914355" rtl="0" eaLnBrk="1" latinLnBrk="0" hangingPunct="1">
-              <a:defRPr sz="1800" kern="1200">
-                <a:solidFill>
-                  <a:schemeClr val="tx1"/>
-                </a:solidFill>
-                <a:latin typeface="+mn-lt"/>
-                <a:ea typeface="+mn-ea"/>
-                <a:cs typeface="+mn-cs"/>
-              </a:defRPr>
-            </a:lvl6pPr>
-            <a:lvl7pPr marL="2743063" algn="l" defTabSz="914355" rtl="0" eaLnBrk="1" latinLnBrk="0" hangingPunct="1">
-              <a:defRPr sz="1800" kern="1200">
-                <a:solidFill>
-                  <a:schemeClr val="tx1"/>
-                </a:solidFill>
-                <a:latin typeface="+mn-lt"/>
-                <a:ea typeface="+mn-ea"/>
-                <a:cs typeface="+mn-cs"/>
-              </a:defRPr>
-            </a:lvl7pPr>
-            <a:lvl8pPr marL="3200240" algn="l" defTabSz="914355" rtl="0" eaLnBrk="1" latinLnBrk="0" hangingPunct="1">
-              <a:defRPr sz="1800" kern="1200">
-                <a:solidFill>
-                  <a:schemeClr val="tx1"/>
-                </a:solidFill>
-                <a:latin typeface="+mn-lt"/>
-                <a:ea typeface="+mn-ea"/>
-                <a:cs typeface="+mn-cs"/>
-              </a:defRPr>
-            </a:lvl8pPr>
-            <a:lvl9pPr marL="3657417" algn="l" defTabSz="914355" rtl="0" eaLnBrk="1" latinLnBrk="0" hangingPunct="1">
-              <a:defRPr sz="1800" kern="1200">
-                <a:solidFill>
-                  <a:schemeClr val="tx1"/>
-                </a:solidFill>
-                <a:latin typeface="+mn-lt"/>
-                <a:ea typeface="+mn-ea"/>
-                <a:cs typeface="+mn-cs"/>
-              </a:defRPr>
-            </a:lvl9pPr>
-          </a:lstStyle>
+          <p:nvPr>
+            <p:ph type="ftr" sz="quarter" idx="3"/>
+          </p:nvPr>
+        </p:nvSpPr>
+        <p:spPr/>
+        <p:txBody>
+          <a:bodyPr/>
+          <a:lstStyle/>
           <a:p>
             <a:r>
-              <a:rPr lang="en-US">
-                <a:solidFill>
-                  <a:srgbClr val="CFE2F3"/>
-                </a:solidFill>
-              </a:rPr>
+              <a:rPr lang="en-US"/>
               <a:t>©</a:t>
             </a:r>
             <a:fld id="{3FEB6F09-2C38-294C-994A-AB349969DE87}" type="datetimeyyyy">
-              <a:rPr lang="en-GB" smtClean="0">
-                <a:solidFill>
-                  <a:srgbClr val="CFE2F3"/>
-                </a:solidFill>
-              </a:rPr>
+              <a:rPr lang="en-GB" smtClean="0"/>
               <a:pPr/>
               <a:t>2026</a:t>
             </a:fld>
             <a:r>
-              <a:rPr lang="en-US">
-                <a:solidFill>
-                  <a:srgbClr val="CFE2F3"/>
-                </a:solidFill>
-              </a:rPr>
+              <a:rPr lang="en-US"/>
               <a:t> TrustFlight Ltd. All rights reserved. </a:t>
             </a:r>
-            <a:endParaRPr lang="en-US" dirty="0">
-              <a:solidFill>
-                <a:srgbClr val="CFE2F3"/>
-              </a:solidFill>
-            </a:endParaRPr>
+            <a:endParaRPr lang="en-US" dirty="0"/>
           </a:p>
         </p:txBody>
       </p:sp>
     </p:spTree>
     <p:extLst>
       <p:ext uri="{BB962C8B-B14F-4D97-AF65-F5344CB8AC3E}">
-        <p14:creationId xmlns:p14="http://schemas.microsoft.com/office/powerpoint/2010/main" val="3450649577"/>
+        <p14:creationId xmlns:p14="http://schemas.microsoft.com/office/powerpoint/2010/main" val="3637964964"/>
       </p:ext>
     </p:extLst>
   </p:cSld>
@@ -9868,7 +9713,7 @@
           <p:cNvPr id="2" name="Slide Number Placeholder 1">
             <a:extLst>
               <a:ext uri="{FF2B5EF4-FFF2-40B4-BE49-F238E27FC236}">
-                <a16:creationId xmlns:a16="http://schemas.microsoft.com/office/drawing/2014/main" id="{C166096B-8C46-3BA2-D97C-4E2EE038240C}"/>
+                <a16:creationId xmlns:a16="http://schemas.microsoft.com/office/drawing/2014/main" id="{63160C2F-E0CD-1504-9385-54E7E6EF935A}"/>
               </a:ext>
             </a:extLst>
           </p:cNvPr>
@@ -9889,7 +9734,7 @@
               <a:pPr/>
               <a:t>4</a:t>
             </a:fld>
-            <a:endParaRPr lang="en-US" dirty="0"/>
+            <a:endParaRPr lang="en-US"/>
           </a:p>
         </p:txBody>
       </p:sp>
@@ -9898,7 +9743,7 @@
           <p:cNvPr id="3" name="Footer Placeholder 2">
             <a:extLst>
               <a:ext uri="{FF2B5EF4-FFF2-40B4-BE49-F238E27FC236}">
-                <a16:creationId xmlns:a16="http://schemas.microsoft.com/office/drawing/2014/main" id="{975C10E2-09F7-A408-DABC-D88E6FD3C20D}"/>
+                <a16:creationId xmlns:a16="http://schemas.microsoft.com/office/drawing/2014/main" id="{C76F4B0A-8182-5264-B86C-1F2C20A32103}"/>
               </a:ext>
             </a:extLst>
           </p:cNvPr>
@@ -9915,7 +9760,7 @@
           <a:lstStyle/>
           <a:p>
             <a:r>
-              <a:rPr lang="en-US" dirty="0"/>
+              <a:rPr lang="en-US"/>
               <a:t>©</a:t>
             </a:r>
             <a:fld id="{3FEB6F09-2C38-294C-994A-AB349969DE87}" type="datetimeyyyy">
@@ -9924,18 +9769,19 @@
               <a:t>2026</a:t>
             </a:fld>
             <a:r>
-              <a:rPr lang="en-US" dirty="0"/>
+              <a:rPr lang="en-US"/>
               <a:t> TrustFlight Ltd. All rights reserved. </a:t>
             </a:r>
-          </a:p>
-        </p:txBody>
-      </p:sp>
-      <p:sp>
-        <p:nvSpPr>
-          <p:cNvPr id="8" name="Title 7">
-            <a:extLst>
-              <a:ext uri="{FF2B5EF4-FFF2-40B4-BE49-F238E27FC236}">
-                <a16:creationId xmlns:a16="http://schemas.microsoft.com/office/drawing/2014/main" id="{44940188-9A3A-52A9-CA08-A8EAC059D15B}"/>
+            <a:endParaRPr lang="en-US" dirty="0"/>
+          </a:p>
+        </p:txBody>
+      </p:sp>
+      <p:sp>
+        <p:nvSpPr>
+          <p:cNvPr id="4" name="Title 3">
+            <a:extLst>
+              <a:ext uri="{FF2B5EF4-FFF2-40B4-BE49-F238E27FC236}">
+                <a16:creationId xmlns:a16="http://schemas.microsoft.com/office/drawing/2014/main" id="{F3807C60-B0CB-243C-55DE-47B43A0828C1}"/>
               </a:ext>
             </a:extLst>
           </p:cNvPr>
@@ -9946,70 +9792,44 @@
             <p:ph type="title"/>
           </p:nvPr>
         </p:nvSpPr>
-        <p:spPr>
-          <a:xfrm>
-            <a:off x="540000" y="774000"/>
-            <a:ext cx="9462670" cy="553998"/>
-          </a:xfrm>
-        </p:spPr>
+        <p:spPr/>
         <p:txBody>
           <a:bodyPr/>
           <a:lstStyle/>
           <a:p>
-            <a:r>
-              <a:rPr lang="en-US" sz="4000" dirty="0"/>
-              <a:t>Slide Title</a:t>
-            </a:r>
-          </a:p>
-        </p:txBody>
-      </p:sp>
-      <p:sp>
-        <p:nvSpPr>
-          <p:cNvPr id="9" name="TextBox 8">
-            <a:extLst>
-              <a:ext uri="{FF2B5EF4-FFF2-40B4-BE49-F238E27FC236}">
-                <a16:creationId xmlns:a16="http://schemas.microsoft.com/office/drawing/2014/main" id="{022D7855-27A0-05F0-C6A3-FAE31F47933A}"/>
-              </a:ext>
-            </a:extLst>
-          </p:cNvPr>
-          <p:cNvSpPr txBox="1"/>
-          <p:nvPr/>
-        </p:nvSpPr>
-        <p:spPr>
-          <a:xfrm>
-            <a:off x="546099" y="1376160"/>
-            <a:ext cx="9396187" cy="307777"/>
-          </a:xfrm>
-          <a:prstGeom prst="rect">
-            <a:avLst/>
-          </a:prstGeom>
-          <a:noFill/>
-        </p:spPr>
-        <p:txBody>
-          <a:bodyPr vertOverflow="overflow" vert="horz" wrap="square" lIns="0" tIns="0" rIns="0" bIns="0" rtlCol="0" anchor="t">
-            <a:spAutoFit/>
-          </a:bodyPr>
+            <a:endParaRPr lang="en-US"/>
+          </a:p>
+        </p:txBody>
+      </p:sp>
+      <p:sp>
+        <p:nvSpPr>
+          <p:cNvPr id="5" name="Content Placeholder 4">
+            <a:extLst>
+              <a:ext uri="{FF2B5EF4-FFF2-40B4-BE49-F238E27FC236}">
+                <a16:creationId xmlns:a16="http://schemas.microsoft.com/office/drawing/2014/main" id="{6A586F00-1797-633A-87D9-51675E0CAB8C}"/>
+              </a:ext>
+            </a:extLst>
+          </p:cNvPr>
+          <p:cNvSpPr>
+            <a:spLocks noGrp="1"/>
+          </p:cNvSpPr>
+          <p:nvPr>
+            <p:ph idx="1"/>
+          </p:nvPr>
+        </p:nvSpPr>
+        <p:spPr/>
+        <p:txBody>
+          <a:bodyPr/>
           <a:lstStyle/>
           <a:p>
-            <a:pPr algn="l"/>
-            <a:r>
-              <a:rPr lang="en-US" sz="2000" dirty="0">
-                <a:solidFill>
-                  <a:srgbClr val="479FF8"/>
-                </a:solidFill>
-                <a:latin typeface="Open Sans SemiBold" pitchFamily="2" charset="0"/>
-                <a:ea typeface="Open Sans SemiBold" pitchFamily="2" charset="0"/>
-                <a:cs typeface="Open Sans SemiBold" pitchFamily="2" charset="0"/>
-              </a:rPr>
-              <a:t>Slide subtitle</a:t>
-            </a:r>
+            <a:endParaRPr lang="en-US"/>
           </a:p>
         </p:txBody>
       </p:sp>
     </p:spTree>
     <p:extLst>
       <p:ext uri="{BB962C8B-B14F-4D97-AF65-F5344CB8AC3E}">
-        <p14:creationId xmlns:p14="http://schemas.microsoft.com/office/powerpoint/2010/main" val="1296111721"/>
+        <p14:creationId xmlns:p14="http://schemas.microsoft.com/office/powerpoint/2010/main" val="2493090838"/>
       </p:ext>
     </p:extLst>
   </p:cSld>
@@ -10038,10 +9858,35 @@
       </p:grpSpPr>
       <p:sp>
         <p:nvSpPr>
-          <p:cNvPr id="2" name="Slide Number Placeholder 1">
-            <a:extLst>
-              <a:ext uri="{FF2B5EF4-FFF2-40B4-BE49-F238E27FC236}">
-                <a16:creationId xmlns:a16="http://schemas.microsoft.com/office/drawing/2014/main" id="{C166096B-8C46-3BA2-D97C-4E2EE038240C}"/>
+          <p:cNvPr id="2" name="Title 1">
+            <a:extLst>
+              <a:ext uri="{FF2B5EF4-FFF2-40B4-BE49-F238E27FC236}">
+                <a16:creationId xmlns:a16="http://schemas.microsoft.com/office/drawing/2014/main" id="{3793FB0E-30DF-CEB1-8EBE-78494FB8AFA2}"/>
+              </a:ext>
+            </a:extLst>
+          </p:cNvPr>
+          <p:cNvSpPr>
+            <a:spLocks noGrp="1"/>
+          </p:cNvSpPr>
+          <p:nvPr>
+            <p:ph type="title"/>
+          </p:nvPr>
+        </p:nvSpPr>
+        <p:spPr/>
+        <p:txBody>
+          <a:bodyPr/>
+          <a:lstStyle/>
+          <a:p>
+            <a:endParaRPr lang="en-US"/>
+          </a:p>
+        </p:txBody>
+      </p:sp>
+      <p:sp>
+        <p:nvSpPr>
+          <p:cNvPr id="3" name="Slide Number Placeholder 2">
+            <a:extLst>
+              <a:ext uri="{FF2B5EF4-FFF2-40B4-BE49-F238E27FC236}">
+                <a16:creationId xmlns:a16="http://schemas.microsoft.com/office/drawing/2014/main" id="{B1DF0C48-CD8C-F961-272A-054233858EC8}"/>
               </a:ext>
             </a:extLst>
           </p:cNvPr>
@@ -10062,16 +9907,41 @@
               <a:pPr/>
               <a:t>5</a:t>
             </a:fld>
-            <a:endParaRPr lang="en-US" dirty="0"/>
-          </a:p>
-        </p:txBody>
-      </p:sp>
-      <p:sp>
-        <p:nvSpPr>
-          <p:cNvPr id="3" name="Footer Placeholder 2">
-            <a:extLst>
-              <a:ext uri="{FF2B5EF4-FFF2-40B4-BE49-F238E27FC236}">
-                <a16:creationId xmlns:a16="http://schemas.microsoft.com/office/drawing/2014/main" id="{975C10E2-09F7-A408-DABC-D88E6FD3C20D}"/>
+            <a:endParaRPr lang="en-US"/>
+          </a:p>
+        </p:txBody>
+      </p:sp>
+      <p:sp>
+        <p:nvSpPr>
+          <p:cNvPr id="4" name="Content Placeholder 3">
+            <a:extLst>
+              <a:ext uri="{FF2B5EF4-FFF2-40B4-BE49-F238E27FC236}">
+                <a16:creationId xmlns:a16="http://schemas.microsoft.com/office/drawing/2014/main" id="{73F2B461-9612-C756-DA96-9BBCFD054262}"/>
+              </a:ext>
+            </a:extLst>
+          </p:cNvPr>
+          <p:cNvSpPr>
+            <a:spLocks noGrp="1"/>
+          </p:cNvSpPr>
+          <p:nvPr>
+            <p:ph idx="1"/>
+          </p:nvPr>
+        </p:nvSpPr>
+        <p:spPr/>
+        <p:txBody>
+          <a:bodyPr/>
+          <a:lstStyle/>
+          <a:p>
+            <a:endParaRPr lang="en-US"/>
+          </a:p>
+        </p:txBody>
+      </p:sp>
+      <p:sp>
+        <p:nvSpPr>
+          <p:cNvPr id="5" name="Footer Placeholder 4">
+            <a:extLst>
+              <a:ext uri="{FF2B5EF4-FFF2-40B4-BE49-F238E27FC236}">
+                <a16:creationId xmlns:a16="http://schemas.microsoft.com/office/drawing/2014/main" id="{20DB10A4-6B13-1C99-866E-42865DD7385D}"/>
               </a:ext>
             </a:extLst>
           </p:cNvPr>
@@ -10088,7 +9958,7 @@
           <a:lstStyle/>
           <a:p>
             <a:r>
-              <a:rPr lang="en-US" dirty="0"/>
+              <a:rPr lang="en-US"/>
               <a:t>©</a:t>
             </a:r>
             <a:fld id="{3FEB6F09-2C38-294C-994A-AB349969DE87}" type="datetimeyyyy">
@@ -10097,92 +9967,17 @@
               <a:t>2026</a:t>
             </a:fld>
             <a:r>
-              <a:rPr lang="en-US" dirty="0"/>
+              <a:rPr lang="en-US"/>
               <a:t> TrustFlight Ltd. All rights reserved. </a:t>
             </a:r>
-          </a:p>
-        </p:txBody>
-      </p:sp>
-      <p:sp>
-        <p:nvSpPr>
-          <p:cNvPr id="10" name="Title 7">
-            <a:extLst>
-              <a:ext uri="{FF2B5EF4-FFF2-40B4-BE49-F238E27FC236}">
-                <a16:creationId xmlns:a16="http://schemas.microsoft.com/office/drawing/2014/main" id="{06E2CBAA-657A-EF27-95BC-D5E773961EF8}"/>
-              </a:ext>
-            </a:extLst>
-          </p:cNvPr>
-          <p:cNvSpPr>
-            <a:spLocks noGrp="1"/>
-          </p:cNvSpPr>
-          <p:nvPr>
-            <p:ph type="title"/>
-          </p:nvPr>
-        </p:nvSpPr>
-        <p:spPr>
-          <a:xfrm>
-            <a:off x="540000" y="774000"/>
-            <a:ext cx="5310467" cy="553998"/>
-          </a:xfrm>
-        </p:spPr>
-        <p:txBody>
-          <a:bodyPr/>
-          <a:lstStyle/>
-          <a:p>
-            <a:r>
-              <a:rPr lang="en-US" sz="4000" dirty="0"/>
-              <a:t>Slide Title</a:t>
-            </a:r>
-          </a:p>
-        </p:txBody>
-      </p:sp>
-      <p:sp>
-        <p:nvSpPr>
-          <p:cNvPr id="12" name="TextBox 11">
-            <a:extLst>
-              <a:ext uri="{FF2B5EF4-FFF2-40B4-BE49-F238E27FC236}">
-                <a16:creationId xmlns:a16="http://schemas.microsoft.com/office/drawing/2014/main" id="{FB3D4EC7-BDE8-0754-7433-BE79F272B7F4}"/>
-              </a:ext>
-            </a:extLst>
-          </p:cNvPr>
-          <p:cNvSpPr txBox="1"/>
-          <p:nvPr/>
-        </p:nvSpPr>
-        <p:spPr>
-          <a:xfrm>
-            <a:off x="546099" y="1376160"/>
-            <a:ext cx="5273157" cy="307777"/>
-          </a:xfrm>
-          <a:prstGeom prst="rect">
-            <a:avLst/>
-          </a:prstGeom>
-          <a:noFill/>
-        </p:spPr>
-        <p:txBody>
-          <a:bodyPr vertOverflow="overflow" vert="horz" wrap="square" lIns="0" tIns="0" rIns="0" bIns="0" rtlCol="0" anchor="t">
-            <a:spAutoFit/>
-          </a:bodyPr>
-          <a:lstStyle/>
-          <a:p>
-            <a:pPr algn="l"/>
-            <a:r>
-              <a:rPr lang="en-US" sz="2000" dirty="0">
-                <a:solidFill>
-                  <a:srgbClr val="479FF8"/>
-                </a:solidFill>
-                <a:latin typeface="Open Sans SemiBold" pitchFamily="2" charset="0"/>
-                <a:ea typeface="Open Sans SemiBold" pitchFamily="2" charset="0"/>
-                <a:cs typeface="Open Sans SemiBold" pitchFamily="2" charset="0"/>
-              </a:rPr>
-              <a:t>Slide subtitle</a:t>
-            </a:r>
+            <a:endParaRPr lang="en-US" dirty="0"/>
           </a:p>
         </p:txBody>
       </p:sp>
     </p:spTree>
     <p:extLst>
       <p:ext uri="{BB962C8B-B14F-4D97-AF65-F5344CB8AC3E}">
-        <p14:creationId xmlns:p14="http://schemas.microsoft.com/office/powerpoint/2010/main" val="3100529834"/>
+        <p14:creationId xmlns:p14="http://schemas.microsoft.com/office/powerpoint/2010/main" val="3820088869"/>
       </p:ext>
     </p:extLst>
   </p:cSld>
@@ -10193,188 +9988,6 @@
 </file>
 
 <file path=ppt/slides/slide6.xml><?xml version="1.0" encoding="utf-8"?>
-<p:sld xmlns:a="http://schemas.openxmlformats.org/drawingml/2006/main" xmlns:r="http://schemas.openxmlformats.org/officeDocument/2006/relationships" xmlns:p="http://schemas.openxmlformats.org/presentationml/2006/main">
-  <p:cSld>
-    <p:bg>
-      <p:bgPr>
-        <a:gradFill>
-          <a:gsLst>
-            <a:gs pos="0">
-              <a:srgbClr val="010306"/>
-            </a:gs>
-            <a:gs pos="100000">
-              <a:srgbClr val="031022"/>
-            </a:gs>
-          </a:gsLst>
-          <a:lin ang="3000000" scaled="0"/>
-        </a:gradFill>
-        <a:effectLst/>
-      </p:bgPr>
-    </p:bg>
-    <p:spTree>
-      <p:nvGrpSpPr>
-        <p:cNvPr id="1" name=""/>
-        <p:cNvGrpSpPr/>
-        <p:nvPr/>
-      </p:nvGrpSpPr>
-      <p:grpSpPr>
-        <a:xfrm>
-          <a:off x="0" y="0"/>
-          <a:ext cx="0" cy="0"/>
-          <a:chOff x="0" y="0"/>
-          <a:chExt cx="0" cy="0"/>
-        </a:xfrm>
-      </p:grpSpPr>
-      <p:sp>
-        <p:nvSpPr>
-          <p:cNvPr id="2" name="Title 1">
-            <a:extLst>
-              <a:ext uri="{FF2B5EF4-FFF2-40B4-BE49-F238E27FC236}">
-                <a16:creationId xmlns:a16="http://schemas.microsoft.com/office/drawing/2014/main" id="{1AA5CB51-C492-0CF3-B897-F182A96F8FE2}"/>
-              </a:ext>
-            </a:extLst>
-          </p:cNvPr>
-          <p:cNvSpPr>
-            <a:spLocks noGrp="1"/>
-          </p:cNvSpPr>
-          <p:nvPr>
-            <p:ph type="title"/>
-          </p:nvPr>
-        </p:nvSpPr>
-        <p:spPr>
-          <a:xfrm>
-            <a:off x="540000" y="773887"/>
-            <a:ext cx="9462670" cy="553998"/>
-          </a:xfrm>
-        </p:spPr>
-        <p:txBody>
-          <a:bodyPr/>
-          <a:lstStyle/>
-          <a:p>
-            <a:r>
-              <a:rPr lang="en-US" sz="4000" dirty="0">
-                <a:solidFill>
-                  <a:schemeClr val="bg1"/>
-                </a:solidFill>
-                <a:latin typeface="Open Sans Light" pitchFamily="2" charset="0"/>
-                <a:ea typeface="Open Sans Light" pitchFamily="2" charset="0"/>
-                <a:cs typeface="Open Sans Light" pitchFamily="2" charset="0"/>
-              </a:rPr>
-              <a:t>Slide Title</a:t>
-            </a:r>
-          </a:p>
-        </p:txBody>
-      </p:sp>
-      <p:sp>
-        <p:nvSpPr>
-          <p:cNvPr id="4" name="Slide Number Placeholder 3">
-            <a:extLst>
-              <a:ext uri="{FF2B5EF4-FFF2-40B4-BE49-F238E27FC236}">
-                <a16:creationId xmlns:a16="http://schemas.microsoft.com/office/drawing/2014/main" id="{910A66E9-8931-42A9-646A-62CD922C3DC7}"/>
-              </a:ext>
-            </a:extLst>
-          </p:cNvPr>
-          <p:cNvSpPr>
-            <a:spLocks noGrp="1"/>
-          </p:cNvSpPr>
-          <p:nvPr>
-            <p:ph type="sldNum" sz="quarter" idx="4"/>
-          </p:nvPr>
-        </p:nvSpPr>
-        <p:spPr/>
-        <p:txBody>
-          <a:bodyPr/>
-          <a:lstStyle/>
-          <a:p>
-            <a:fld id="{1B377F6A-2966-294D-95D7-FBB58FDBE7CB}" type="slidenum">
-              <a:rPr lang="en-US" smtClean="0"/>
-              <a:pPr/>
-              <a:t>6</a:t>
-            </a:fld>
-            <a:endParaRPr lang="en-US"/>
-          </a:p>
-        </p:txBody>
-      </p:sp>
-      <p:sp>
-        <p:nvSpPr>
-          <p:cNvPr id="5" name="Footer Placeholder 4">
-            <a:extLst>
-              <a:ext uri="{FF2B5EF4-FFF2-40B4-BE49-F238E27FC236}">
-                <a16:creationId xmlns:a16="http://schemas.microsoft.com/office/drawing/2014/main" id="{911098A5-FDA6-218B-8FDA-301521600D35}"/>
-              </a:ext>
-            </a:extLst>
-          </p:cNvPr>
-          <p:cNvSpPr>
-            <a:spLocks noGrp="1"/>
-          </p:cNvSpPr>
-          <p:nvPr>
-            <p:ph type="ftr" sz="quarter" idx="3"/>
-          </p:nvPr>
-        </p:nvSpPr>
-        <p:spPr>
-          <a:xfrm>
-            <a:off x="540000" y="6461968"/>
-            <a:ext cx="3078186" cy="153888"/>
-          </a:xfrm>
-          <a:prstGeom prst="rect">
-            <a:avLst/>
-          </a:prstGeom>
-        </p:spPr>
-        <p:txBody>
-          <a:bodyPr vert="horz" wrap="square" lIns="0" tIns="0" rIns="0" bIns="0" rtlCol="0" anchor="ctr">
-            <a:spAutoFit/>
-          </a:bodyPr>
-          <a:lstStyle>
-            <a:lvl1pPr algn="l">
-              <a:defRPr sz="1000" b="0" i="0">
-                <a:solidFill>
-                  <a:srgbClr val="242D41"/>
-                </a:solidFill>
-                <a:latin typeface="Open Sans Light" panose="020B0306030504020204" pitchFamily="34" charset="0"/>
-                <a:ea typeface="Open Sans Light" panose="020B0306030504020204" pitchFamily="34" charset="0"/>
-                <a:cs typeface="Open Sans Light" panose="020B0306030504020204" pitchFamily="34" charset="0"/>
-              </a:defRPr>
-            </a:lvl1pPr>
-          </a:lstStyle>
-          <a:p>
-            <a:r>
-              <a:rPr lang="en-US" dirty="0"/>
-              <a:t>©</a:t>
-            </a:r>
-            <a:fld id="{3FEB6F09-2C38-294C-994A-AB349969DE87}" type="datetimeyyyy">
-              <a:rPr lang="en-GB" smtClean="0"/>
-              <a:pPr/>
-              <a:t>2026</a:t>
-            </a:fld>
-            <a:r>
-              <a:rPr lang="en-US" dirty="0"/>
-              <a:t> </a:t>
-            </a:r>
-            <a:r>
-              <a:rPr lang="en-US" dirty="0" err="1"/>
-              <a:t>TrustFlight</a:t>
-            </a:r>
-            <a:r>
-              <a:rPr lang="en-US" dirty="0"/>
-              <a:t> Ltd. All rights reserved. </a:t>
-            </a:r>
-          </a:p>
-        </p:txBody>
-      </p:sp>
-    </p:spTree>
-    <p:extLst>
-      <p:ext uri="{BB962C8B-B14F-4D97-AF65-F5344CB8AC3E}">
-        <p14:creationId xmlns:p14="http://schemas.microsoft.com/office/powerpoint/2010/main" val="2701429794"/>
-      </p:ext>
-    </p:extLst>
-  </p:cSld>
-  <p:clrMapOvr>
-    <a:masterClrMapping/>
-  </p:clrMapOvr>
-</p:sld>
-</file>
-
-<file path=ppt/slides/slide7.xml><?xml version="1.0" encoding="utf-8"?>
 <p:sld xmlns:a="http://schemas.openxmlformats.org/drawingml/2006/main" xmlns:r="http://schemas.openxmlformats.org/officeDocument/2006/relationships" xmlns:p="http://schemas.openxmlformats.org/presentationml/2006/main">
   <p:cSld>
     <p:spTree>
@@ -10396,7 +10009,7 @@
           <p:cNvPr id="2" name="Title 1">
             <a:extLst>
               <a:ext uri="{FF2B5EF4-FFF2-40B4-BE49-F238E27FC236}">
-                <a16:creationId xmlns:a16="http://schemas.microsoft.com/office/drawing/2014/main" id="{D7142FB2-D27B-8EA1-E477-92FB93D5906E}"/>
+                <a16:creationId xmlns:a16="http://schemas.microsoft.com/office/drawing/2014/main" id="{D558C542-F48D-CFB7-9239-EF3E35DF399B}"/>
               </a:ext>
             </a:extLst>
           </p:cNvPr>
@@ -10407,29 +10020,46 @@
             <p:ph type="title"/>
           </p:nvPr>
         </p:nvSpPr>
-        <p:spPr>
-          <a:xfrm>
-            <a:off x="540000" y="774000"/>
-            <a:ext cx="9462670" cy="553998"/>
-          </a:xfrm>
-        </p:spPr>
+        <p:spPr/>
         <p:txBody>
           <a:bodyPr/>
           <a:lstStyle/>
           <a:p>
-            <a:r>
-              <a:rPr lang="en-US" sz="4000" dirty="0"/>
-              <a:t>Slide Title</a:t>
-            </a:r>
-          </a:p>
-        </p:txBody>
-      </p:sp>
-      <p:sp>
-        <p:nvSpPr>
-          <p:cNvPr id="5" name="Slide Number Placeholder 4">
-            <a:extLst>
-              <a:ext uri="{FF2B5EF4-FFF2-40B4-BE49-F238E27FC236}">
-                <a16:creationId xmlns:a16="http://schemas.microsoft.com/office/drawing/2014/main" id="{68562A10-B3FE-CCD6-3B68-053CD49D0462}"/>
+            <a:endParaRPr lang="en-US"/>
+          </a:p>
+        </p:txBody>
+      </p:sp>
+      <p:sp>
+        <p:nvSpPr>
+          <p:cNvPr id="3" name="Content Placeholder 2">
+            <a:extLst>
+              <a:ext uri="{FF2B5EF4-FFF2-40B4-BE49-F238E27FC236}">
+                <a16:creationId xmlns:a16="http://schemas.microsoft.com/office/drawing/2014/main" id="{3D262D27-F90B-7ABA-8528-5B72E313866B}"/>
+              </a:ext>
+            </a:extLst>
+          </p:cNvPr>
+          <p:cNvSpPr>
+            <a:spLocks noGrp="1"/>
+          </p:cNvSpPr>
+          <p:nvPr>
+            <p:ph idx="1"/>
+          </p:nvPr>
+        </p:nvSpPr>
+        <p:spPr/>
+        <p:txBody>
+          <a:bodyPr/>
+          <a:lstStyle/>
+          <a:p>
+            <a:endParaRPr lang="en-US"/>
+          </a:p>
+        </p:txBody>
+      </p:sp>
+      <p:sp>
+        <p:nvSpPr>
+          <p:cNvPr id="4" name="Slide Number Placeholder 3">
+            <a:extLst>
+              <a:ext uri="{FF2B5EF4-FFF2-40B4-BE49-F238E27FC236}">
+                <a16:creationId xmlns:a16="http://schemas.microsoft.com/office/drawing/2014/main" id="{E48FCD0B-F506-7F8F-C50B-35934BAF2C5B}"/>
               </a:ext>
             </a:extLst>
           </p:cNvPr>
@@ -10448,7 +10078,7 @@
             <a:fld id="{1B377F6A-2966-294D-95D7-FBB58FDBE7CB}" type="slidenum">
               <a:rPr lang="en-US" smtClean="0"/>
               <a:pPr/>
-              <a:t>7</a:t>
+              <a:t>6</a:t>
             </a:fld>
             <a:endParaRPr lang="en-US"/>
           </a:p>
@@ -10456,244 +10086,10 @@
       </p:sp>
       <p:sp>
         <p:nvSpPr>
-          <p:cNvPr id="12" name="Content Placeholder 4">
-            <a:extLst>
-              <a:ext uri="{FF2B5EF4-FFF2-40B4-BE49-F238E27FC236}">
-                <a16:creationId xmlns:a16="http://schemas.microsoft.com/office/drawing/2014/main" id="{7A6A3014-D139-ED15-CA4C-45DFB26D1B85}"/>
-              </a:ext>
-            </a:extLst>
-          </p:cNvPr>
-          <p:cNvSpPr txBox="1">
-            <a:spLocks/>
-          </p:cNvSpPr>
-          <p:nvPr/>
-        </p:nvSpPr>
-        <p:spPr>
-          <a:xfrm>
-            <a:off x="540000" y="1382429"/>
-            <a:ext cx="6905829" cy="215444"/>
-          </a:xfrm>
-          <a:prstGeom prst="rect">
-            <a:avLst/>
-          </a:prstGeom>
-        </p:spPr>
-        <p:txBody>
-          <a:bodyPr vert="horz" wrap="square" lIns="0" tIns="0" rIns="0" bIns="0" rtlCol="0">
-            <a:spAutoFit/>
-          </a:bodyPr>
-          <a:lstStyle>
-            <a:lvl1pPr marL="228589" indent="-228589" algn="l" defTabSz="914355" rtl="0" eaLnBrk="1" latinLnBrk="0" hangingPunct="1">
-              <a:lnSpc>
-                <a:spcPct val="90000"/>
-              </a:lnSpc>
-              <a:spcBef>
-                <a:spcPts val="1000"/>
-              </a:spcBef>
-              <a:buClr>
-                <a:srgbClr val="1E5BB5"/>
-              </a:buClr>
-              <a:buFont typeface="Arial" panose="020B0604020202020204" pitchFamily="34" charset="0"/>
-              <a:buChar char="•"/>
-              <a:defRPr sz="2400" b="0" i="0" kern="1200">
-                <a:solidFill>
-                  <a:schemeClr val="bg1"/>
-                </a:solidFill>
-                <a:latin typeface="Open Sans Light" panose="020B0606030504020204" pitchFamily="34" charset="0"/>
-                <a:ea typeface="Open Sans Light" panose="020B0606030504020204" pitchFamily="34" charset="0"/>
-                <a:cs typeface="Open Sans Light" panose="020B0606030504020204" pitchFamily="34" charset="0"/>
-              </a:defRPr>
-            </a:lvl1pPr>
-            <a:lvl2pPr marL="685766" indent="-228589" algn="l" defTabSz="914355" rtl="0" eaLnBrk="1" latinLnBrk="0" hangingPunct="1">
-              <a:lnSpc>
-                <a:spcPct val="90000"/>
-              </a:lnSpc>
-              <a:spcBef>
-                <a:spcPts val="500"/>
-              </a:spcBef>
-              <a:buClr>
-                <a:srgbClr val="1E5BB5"/>
-              </a:buClr>
-              <a:buFont typeface="Arial" panose="020B0604020202020204" pitchFamily="34" charset="0"/>
-              <a:buChar char="•"/>
-              <a:defRPr sz="1400" b="0" i="0" kern="1200">
-                <a:solidFill>
-                  <a:srgbClr val="E0E8F7"/>
-                </a:solidFill>
-                <a:latin typeface="Open Sans Light" panose="020B0606030504020204" pitchFamily="34" charset="0"/>
-                <a:ea typeface="Open Sans Light" panose="020B0606030504020204" pitchFamily="34" charset="0"/>
-                <a:cs typeface="Open Sans Light" panose="020B0606030504020204" pitchFamily="34" charset="0"/>
-              </a:defRPr>
-            </a:lvl2pPr>
-            <a:lvl3pPr marL="1142943" indent="-228589" algn="l" defTabSz="914355" rtl="0" eaLnBrk="1" latinLnBrk="0" hangingPunct="1">
-              <a:lnSpc>
-                <a:spcPct val="90000"/>
-              </a:lnSpc>
-              <a:spcBef>
-                <a:spcPts val="500"/>
-              </a:spcBef>
-              <a:buClr>
-                <a:srgbClr val="1E5BB5"/>
-              </a:buClr>
-              <a:buFont typeface="Arial" panose="020B0604020202020204" pitchFamily="34" charset="0"/>
-              <a:buChar char="•"/>
-              <a:defRPr sz="1400" b="0" i="0" kern="1200">
-                <a:solidFill>
-                  <a:srgbClr val="E0E8F7"/>
-                </a:solidFill>
-                <a:latin typeface="Open Sans Light" panose="020B0606030504020204" pitchFamily="34" charset="0"/>
-                <a:ea typeface="Open Sans Light" panose="020B0606030504020204" pitchFamily="34" charset="0"/>
-                <a:cs typeface="Open Sans Light" panose="020B0606030504020204" pitchFamily="34" charset="0"/>
-              </a:defRPr>
-            </a:lvl3pPr>
-            <a:lvl4pPr marL="1600120" indent="-228589" algn="l" defTabSz="914355" rtl="0" eaLnBrk="1" latinLnBrk="0" hangingPunct="1">
-              <a:lnSpc>
-                <a:spcPct val="90000"/>
-              </a:lnSpc>
-              <a:spcBef>
-                <a:spcPts val="500"/>
-              </a:spcBef>
-              <a:buClr>
-                <a:srgbClr val="1E5BB5"/>
-              </a:buClr>
-              <a:buFont typeface="Arial" panose="020B0604020202020204" pitchFamily="34" charset="0"/>
-              <a:buChar char="•"/>
-              <a:defRPr sz="1400" b="0" i="0" kern="1200">
-                <a:solidFill>
-                  <a:srgbClr val="E0E8F7"/>
-                </a:solidFill>
-                <a:latin typeface="Open Sans Light" panose="020B0606030504020204" pitchFamily="34" charset="0"/>
-                <a:ea typeface="Open Sans Light" panose="020B0606030504020204" pitchFamily="34" charset="0"/>
-                <a:cs typeface="Open Sans Light" panose="020B0606030504020204" pitchFamily="34" charset="0"/>
-              </a:defRPr>
-            </a:lvl4pPr>
-            <a:lvl5pPr marL="2057297" indent="-228589" algn="l" defTabSz="914355" rtl="0" eaLnBrk="1" latinLnBrk="0" hangingPunct="1">
-              <a:lnSpc>
-                <a:spcPct val="90000"/>
-              </a:lnSpc>
-              <a:spcBef>
-                <a:spcPts val="500"/>
-              </a:spcBef>
-              <a:buClr>
-                <a:srgbClr val="1E5BB5"/>
-              </a:buClr>
-              <a:buFont typeface="Arial" panose="020B0604020202020204" pitchFamily="34" charset="0"/>
-              <a:buChar char="•"/>
-              <a:defRPr sz="1400" b="0" i="0" kern="1200">
-                <a:solidFill>
-                  <a:srgbClr val="E0E8F7"/>
-                </a:solidFill>
-                <a:latin typeface="Open Sans Light" panose="020B0606030504020204" pitchFamily="34" charset="0"/>
-                <a:ea typeface="Open Sans Light" panose="020B0606030504020204" pitchFamily="34" charset="0"/>
-                <a:cs typeface="Open Sans Light" panose="020B0606030504020204" pitchFamily="34" charset="0"/>
-              </a:defRPr>
-            </a:lvl5pPr>
-            <a:lvl6pPr marL="2514475" indent="-228589" algn="l" defTabSz="914355" rtl="0" eaLnBrk="1" latinLnBrk="0" hangingPunct="1">
-              <a:lnSpc>
-                <a:spcPct val="90000"/>
-              </a:lnSpc>
-              <a:spcBef>
-                <a:spcPts val="500"/>
-              </a:spcBef>
-              <a:buFont typeface="Arial" panose="020B0604020202020204" pitchFamily="34" charset="0"/>
-              <a:buChar char="•"/>
-              <a:defRPr sz="1800" kern="1200">
-                <a:solidFill>
-                  <a:schemeClr val="tx1"/>
-                </a:solidFill>
-                <a:latin typeface="+mn-lt"/>
-                <a:ea typeface="+mn-ea"/>
-                <a:cs typeface="+mn-cs"/>
-              </a:defRPr>
-            </a:lvl6pPr>
-            <a:lvl7pPr marL="2971652" indent="-228589" algn="l" defTabSz="914355" rtl="0" eaLnBrk="1" latinLnBrk="0" hangingPunct="1">
-              <a:lnSpc>
-                <a:spcPct val="90000"/>
-              </a:lnSpc>
-              <a:spcBef>
-                <a:spcPts val="500"/>
-              </a:spcBef>
-              <a:buFont typeface="Arial" panose="020B0604020202020204" pitchFamily="34" charset="0"/>
-              <a:buChar char="•"/>
-              <a:defRPr sz="1800" kern="1200">
-                <a:solidFill>
-                  <a:schemeClr val="tx1"/>
-                </a:solidFill>
-                <a:latin typeface="+mn-lt"/>
-                <a:ea typeface="+mn-ea"/>
-                <a:cs typeface="+mn-cs"/>
-              </a:defRPr>
-            </a:lvl7pPr>
-            <a:lvl8pPr marL="3428829" indent="-228589" algn="l" defTabSz="914355" rtl="0" eaLnBrk="1" latinLnBrk="0" hangingPunct="1">
-              <a:lnSpc>
-                <a:spcPct val="90000"/>
-              </a:lnSpc>
-              <a:spcBef>
-                <a:spcPts val="500"/>
-              </a:spcBef>
-              <a:buFont typeface="Arial" panose="020B0604020202020204" pitchFamily="34" charset="0"/>
-              <a:buChar char="•"/>
-              <a:defRPr sz="1800" kern="1200">
-                <a:solidFill>
-                  <a:schemeClr val="tx1"/>
-                </a:solidFill>
-                <a:latin typeface="+mn-lt"/>
-                <a:ea typeface="+mn-ea"/>
-                <a:cs typeface="+mn-cs"/>
-              </a:defRPr>
-            </a:lvl8pPr>
-            <a:lvl9pPr marL="3886006" indent="-228589" algn="l" defTabSz="914355" rtl="0" eaLnBrk="1" latinLnBrk="0" hangingPunct="1">
-              <a:lnSpc>
-                <a:spcPct val="90000"/>
-              </a:lnSpc>
-              <a:spcBef>
-                <a:spcPts val="500"/>
-              </a:spcBef>
-              <a:buFont typeface="Arial" panose="020B0604020202020204" pitchFamily="34" charset="0"/>
-              <a:buChar char="•"/>
-              <a:defRPr sz="1800" kern="1200">
-                <a:solidFill>
-                  <a:schemeClr val="tx1"/>
-                </a:solidFill>
-                <a:latin typeface="+mn-lt"/>
-                <a:ea typeface="+mn-ea"/>
-                <a:cs typeface="+mn-cs"/>
-              </a:defRPr>
-            </a:lvl9pPr>
-          </a:lstStyle>
-          <a:p>
-            <a:pPr marL="0" indent="0">
-              <a:lnSpc>
-                <a:spcPct val="100000"/>
-              </a:lnSpc>
-              <a:spcAft>
-                <a:spcPts val="600"/>
-              </a:spcAft>
-              <a:buClr>
-                <a:srgbClr val="479FF8"/>
-              </a:buClr>
-              <a:buSzPct val="150000"/>
-              <a:buNone/>
-            </a:pPr>
-            <a:r>
-              <a:rPr lang="en-US" sz="1400" b="1" dirty="0">
-                <a:solidFill>
-                  <a:srgbClr val="1E5BB5"/>
-                </a:solidFill>
-                <a:latin typeface="Open Sans SemiBold" pitchFamily="2" charset="0"/>
-                <a:ea typeface="Open Sans SemiBold" pitchFamily="2" charset="0"/>
-                <a:cs typeface="Open Sans SemiBold" pitchFamily="2" charset="0"/>
-              </a:rPr>
-              <a:t>Slide subtitle</a:t>
-            </a:r>
-          </a:p>
-        </p:txBody>
-      </p:sp>
-      <p:sp>
-        <p:nvSpPr>
-          <p:cNvPr id="8" name="Footer Placeholder 4">
-            <a:extLst>
-              <a:ext uri="{FF2B5EF4-FFF2-40B4-BE49-F238E27FC236}">
-                <a16:creationId xmlns:a16="http://schemas.microsoft.com/office/drawing/2014/main" id="{CD32B7AD-73A8-00A3-C5D2-3206338E264D}"/>
+          <p:cNvPr id="5" name="Footer Placeholder 4">
+            <a:extLst>
+              <a:ext uri="{FF2B5EF4-FFF2-40B4-BE49-F238E27FC236}">
+                <a16:creationId xmlns:a16="http://schemas.microsoft.com/office/drawing/2014/main" id="{E3F37524-98B4-8511-19B5-87C89A6505BF}"/>
               </a:ext>
             </a:extLst>
           </p:cNvPr>
@@ -10704,34 +10100,13 @@
             <p:ph type="ftr" sz="quarter" idx="3"/>
           </p:nvPr>
         </p:nvSpPr>
-        <p:spPr>
-          <a:xfrm>
-            <a:off x="540000" y="6461968"/>
-            <a:ext cx="3078186" cy="153888"/>
-          </a:xfrm>
-          <a:prstGeom prst="rect">
-            <a:avLst/>
-          </a:prstGeom>
-        </p:spPr>
-        <p:txBody>
-          <a:bodyPr vert="horz" wrap="square" lIns="0" tIns="0" rIns="0" bIns="0" rtlCol="0" anchor="ctr">
-            <a:spAutoFit/>
-          </a:bodyPr>
-          <a:lstStyle>
-            <a:lvl1pPr algn="l">
-              <a:defRPr sz="1000" b="0" i="0">
-                <a:solidFill>
-                  <a:srgbClr val="242D41"/>
-                </a:solidFill>
-                <a:latin typeface="Open Sans Light" panose="020B0306030504020204" pitchFamily="34" charset="0"/>
-                <a:ea typeface="Open Sans Light" panose="020B0306030504020204" pitchFamily="34" charset="0"/>
-                <a:cs typeface="Open Sans Light" panose="020B0306030504020204" pitchFamily="34" charset="0"/>
-              </a:defRPr>
-            </a:lvl1pPr>
-          </a:lstStyle>
+        <p:spPr/>
+        <p:txBody>
+          <a:bodyPr/>
+          <a:lstStyle/>
           <a:p>
             <a:r>
-              <a:rPr lang="en-US" dirty="0"/>
+              <a:rPr lang="en-US"/>
               <a:t>©</a:t>
             </a:r>
             <a:fld id="{3FEB6F09-2C38-294C-994A-AB349969DE87}" type="datetimeyyyy">
@@ -10740,24 +10115,17 @@
               <a:t>2026</a:t>
             </a:fld>
             <a:r>
-              <a:rPr lang="en-US" dirty="0"/>
-              <a:t> </a:t>
+              <a:rPr lang="en-US"/>
+              <a:t> TrustFlight Ltd. All rights reserved. </a:t>
             </a:r>
-            <a:r>
-              <a:rPr lang="en-US" dirty="0" err="1"/>
-              <a:t>TrustFlight</a:t>
-            </a:r>
-            <a:r>
-              <a:rPr lang="en-US" dirty="0"/>
-              <a:t> Ltd. All rights reserved. </a:t>
-            </a:r>
+            <a:endParaRPr lang="en-US" dirty="0"/>
           </a:p>
         </p:txBody>
       </p:sp>
     </p:spTree>
     <p:extLst>
       <p:ext uri="{BB962C8B-B14F-4D97-AF65-F5344CB8AC3E}">
-        <p14:creationId xmlns:p14="http://schemas.microsoft.com/office/powerpoint/2010/main" val="3379980577"/>
+        <p14:creationId xmlns:p14="http://schemas.microsoft.com/office/powerpoint/2010/main" val="4141893985"/>
       </p:ext>
     </p:extLst>
   </p:cSld>
@@ -10767,7 +10135,7 @@
 </p:sld>
 </file>
 
-<file path=ppt/slides/slide8.xml><?xml version="1.0" encoding="utf-8"?>
+<file path=ppt/slides/slide7.xml><?xml version="1.0" encoding="utf-8"?>
 <p:sld xmlns:a="http://schemas.openxmlformats.org/drawingml/2006/main" xmlns:r="http://schemas.openxmlformats.org/officeDocument/2006/relationships" xmlns:p="http://schemas.openxmlformats.org/presentationml/2006/main">
   <p:cSld>
     <p:spTree>
@@ -12922,6 +12290,15 @@
 </file>
 
 <file path=customXml/item2.xml><?xml version="1.0" encoding="utf-8"?>
+<?mso-contentType ?>
+<FormTemplates xmlns="http://schemas.microsoft.com/sharepoint/v3/contenttype/forms">
+  <Display>DocumentLibraryForm</Display>
+  <Edit>DocumentLibraryForm</Edit>
+  <New>DocumentLibraryForm</New>
+</FormTemplates>
+</file>
+
+<file path=customXml/item3.xml><?xml version="1.0" encoding="utf-8"?>
 <p:properties xmlns:p="http://schemas.microsoft.com/office/2006/metadata/properties" xmlns:xsi="http://www.w3.org/2001/XMLSchema-instance" xmlns:pc="http://schemas.microsoft.com/office/infopath/2007/PartnerControls">
   <documentManagement>
     <lcf76f155ced4ddcb4097134ff3c332f xmlns="786f6ea3-4ea6-437c-a297-c135d4f2e74c">
@@ -12930,15 +12307,6 @@
     <TaxCatchAll xmlns="f61f66a0-0880-4c0b-b123-6e5c0c961f27" xsi:nil="true"/>
   </documentManagement>
 </p:properties>
-</file>
-
-<file path=customXml/item3.xml><?xml version="1.0" encoding="utf-8"?>
-<?mso-contentType ?>
-<FormTemplates xmlns="http://schemas.microsoft.com/sharepoint/v3/contenttype/forms">
-  <Display>DocumentLibraryForm</Display>
-  <Edit>DocumentLibraryForm</Edit>
-  <New>DocumentLibraryForm</New>
-</FormTemplates>
 </file>
 
 <file path=customXml/itemProps1.xml><?xml version="1.0" encoding="utf-8"?>
@@ -12961,26 +12329,26 @@
 </file>
 
 <file path=customXml/itemProps2.xml><?xml version="1.0" encoding="utf-8"?>
-<ds:datastoreItem xmlns:ds="http://schemas.openxmlformats.org/officeDocument/2006/customXml" ds:itemID="{33EAB162-098D-4AAD-B447-7AA8F957B0D7}">
+<ds:datastoreItem xmlns:ds="http://schemas.openxmlformats.org/officeDocument/2006/customXml" ds:itemID="{DAB22FEE-1B56-42A8-8CFB-FF76A629D598}">
   <ds:schemaRefs>
-    <ds:schemaRef ds:uri="786f6ea3-4ea6-437c-a297-c135d4f2e74c"/>
-    <ds:schemaRef ds:uri="http://schemas.openxmlformats.org/package/2006/metadata/core-properties"/>
-    <ds:schemaRef ds:uri="http://purl.org/dc/elements/1.1/"/>
-    <ds:schemaRef ds:uri="http://schemas.microsoft.com/office/2006/documentManagement/types"/>
-    <ds:schemaRef ds:uri="http://purl.org/dc/dcmitype/"/>
-    <ds:schemaRef ds:uri="http://purl.org/dc/terms/"/>
-    <ds:schemaRef ds:uri="http://schemas.microsoft.com/office/2006/metadata/properties"/>
-    <ds:schemaRef ds:uri="http://schemas.microsoft.com/office/infopath/2007/PartnerControls"/>
-    <ds:schemaRef ds:uri="f61f66a0-0880-4c0b-b123-6e5c0c961f27"/>
-    <ds:schemaRef ds:uri="http://www.w3.org/XML/1998/namespace"/>
+    <ds:schemaRef ds:uri="http://schemas.microsoft.com/sharepoint/v3/contenttype/forms"/>
   </ds:schemaRefs>
 </ds:datastoreItem>
 </file>
 
 <file path=customXml/itemProps3.xml><?xml version="1.0" encoding="utf-8"?>
-<ds:datastoreItem xmlns:ds="http://schemas.openxmlformats.org/officeDocument/2006/customXml" ds:itemID="{DAB22FEE-1B56-42A8-8CFB-FF76A629D598}">
+<ds:datastoreItem xmlns:ds="http://schemas.openxmlformats.org/officeDocument/2006/customXml" ds:itemID="{33EAB162-098D-4AAD-B447-7AA8F957B0D7}">
   <ds:schemaRefs>
-    <ds:schemaRef ds:uri="http://schemas.microsoft.com/sharepoint/v3/contenttype/forms"/>
+    <ds:schemaRef ds:uri="http://purl.org/dc/terms/"/>
+    <ds:schemaRef ds:uri="http://schemas.microsoft.com/office/2006/metadata/properties"/>
+    <ds:schemaRef ds:uri="786f6ea3-4ea6-437c-a297-c135d4f2e74c"/>
+    <ds:schemaRef ds:uri="f61f66a0-0880-4c0b-b123-6e5c0c961f27"/>
+    <ds:schemaRef ds:uri="http://schemas.microsoft.com/office/infopath/2007/PartnerControls"/>
+    <ds:schemaRef ds:uri="http://purl.org/dc/elements/1.1/"/>
+    <ds:schemaRef ds:uri="http://schemas.microsoft.com/office/2006/documentManagement/types"/>
+    <ds:schemaRef ds:uri="http://www.w3.org/XML/1998/namespace"/>
+    <ds:schemaRef ds:uri="http://schemas.openxmlformats.org/package/2006/metadata/core-properties"/>
+    <ds:schemaRef ds:uri="http://purl.org/dc/dcmitype/"/>
   </ds:schemaRefs>
 </ds:datastoreItem>
 </file>
</xml_diff>